<commit_message>
Fix B1Pay presentation header overlap
</commit_message>
<xml_diff>
--- a/deliverables/octo-business/output/B1Pay_Octo_Partner_Proposal.pptx
+++ b/deliverables/octo-business/output/B1Pay_Octo_Partner_Proposal.pptx
@@ -3153,6 +3153,120 @@
         </p:nvSpPr>
         <p:spPr>
           <a:xfrm>
+            <a:off x="502920" y="164592"/>
+            <a:ext cx="1828800" cy="301752"/>
+          </a:xfrm>
+          <a:prstGeom prst="rect">
+            <a:avLst/>
+          </a:prstGeom>
+          <a:noFill/>
+        </p:spPr>
+        <p:txBody>
+          <a:bodyPr wrap="square" lIns="36576" rIns="36576">
+            <a:spAutoFit/>
+          </a:bodyPr>
+          <a:lstStyle/>
+          <a:p>
+            <a:pPr algn="l"/>
+            <a:r>
+              <a:rPr sz="1800" b="1">
+                <a:solidFill>
+                  <a:srgbClr val="1264D6"/>
+                </a:solidFill>
+                <a:latin typeface="Aptos"/>
+              </a:rPr>
+              <a:t>B1</a:t>
+            </a:r>
+            <a:r>
+              <a:rPr sz="1800" b="1">
+                <a:solidFill>
+                  <a:srgbClr val="FFFFFF"/>
+                </a:solidFill>
+                <a:latin typeface="Aptos"/>
+              </a:rPr>
+              <a:t>Pay</a:t>
+            </a:r>
+          </a:p>
+        </p:txBody>
+      </p:sp>
+      <p:sp>
+        <p:nvSpPr>
+          <p:cNvPr id="4" name="TextBox 3"/>
+          <p:cNvSpPr txBox="1"/>
+          <p:nvPr/>
+        </p:nvSpPr>
+        <p:spPr>
+          <a:xfrm>
+            <a:off x="658368" y="566928"/>
+            <a:ext cx="6217920" cy="384048"/>
+          </a:xfrm>
+          <a:prstGeom prst="rect">
+            <a:avLst/>
+          </a:prstGeom>
+          <a:noFill/>
+        </p:spPr>
+        <p:txBody>
+          <a:bodyPr wrap="square" lIns="36576" rIns="36576" tIns="36576" bIns="36576" anchor="t">
+            <a:spAutoFit/>
+          </a:bodyPr>
+          <a:lstStyle/>
+          <a:p>
+            <a:pPr algn="l"/>
+            <a:r>
+              <a:rPr sz="2400" b="1" i="0">
+                <a:solidFill>
+                  <a:srgbClr val="FFFFFF"/>
+                </a:solidFill>
+                <a:latin typeface="Aptos"/>
+              </a:rPr>
+              <a:t>B1Pay × Octo</a:t>
+            </a:r>
+          </a:p>
+        </p:txBody>
+      </p:sp>
+      <p:sp>
+        <p:nvSpPr>
+          <p:cNvPr id="5" name="TextBox 4"/>
+          <p:cNvSpPr txBox="1"/>
+          <p:nvPr/>
+        </p:nvSpPr>
+        <p:spPr>
+          <a:xfrm>
+            <a:off x="694944" y="960120"/>
+            <a:ext cx="10424160" cy="310896"/>
+          </a:xfrm>
+          <a:prstGeom prst="rect">
+            <a:avLst/>
+          </a:prstGeom>
+          <a:noFill/>
+        </p:spPr>
+        <p:txBody>
+          <a:bodyPr wrap="square" lIns="36576" rIns="36576" tIns="36576" bIns="36576" anchor="t">
+            <a:spAutoFit/>
+          </a:bodyPr>
+          <a:lstStyle/>
+          <a:p>
+            <a:pPr algn="l"/>
+            <a:r>
+              <a:rPr sz="1200" b="0" i="0">
+                <a:solidFill>
+                  <a:srgbClr val="BED3EB"/>
+                </a:solidFill>
+                <a:latin typeface="Aptos"/>
+              </a:rPr>
+              <a:t>Партнёрская модель цифровой финансовой платформы для Узбекистана</a:t>
+            </a:r>
+          </a:p>
+        </p:txBody>
+      </p:sp>
+      <p:sp>
+        <p:nvSpPr>
+          <p:cNvPr id="6" name="TextBox 5"/>
+          <p:cNvSpPr txBox="1"/>
+          <p:nvPr/>
+        </p:nvSpPr>
+        <p:spPr>
+          <a:xfrm>
             <a:off x="658368" y="1389888"/>
             <a:ext cx="10241280" cy="822960"/>
           </a:xfrm>
@@ -3182,7 +3296,7 @@
       </p:sp>
       <p:sp>
         <p:nvSpPr>
-          <p:cNvPr id="4" name="TextBox 3"/>
+          <p:cNvPr id="7" name="TextBox 6"/>
           <p:cNvSpPr txBox="1"/>
           <p:nvPr/>
         </p:nvSpPr>
@@ -3217,7 +3331,7 @@
       </p:sp>
       <p:sp>
         <p:nvSpPr>
-          <p:cNvPr id="5" name="Rounded Rectangle 4"/>
+          <p:cNvPr id="8" name="Rounded Rectangle 7"/>
           <p:cNvSpPr/>
           <p:nvPr/>
         </p:nvSpPr>
@@ -3262,7 +3376,7 @@
       </p:sp>
       <p:sp>
         <p:nvSpPr>
-          <p:cNvPr id="6" name="Rectangle 5"/>
+          <p:cNvPr id="9" name="Rectangle 8"/>
           <p:cNvSpPr/>
           <p:nvPr/>
         </p:nvSpPr>
@@ -3305,7 +3419,7 @@
       </p:sp>
       <p:sp>
         <p:nvSpPr>
-          <p:cNvPr id="7" name="TextBox 6"/>
+          <p:cNvPr id="10" name="TextBox 9"/>
           <p:cNvSpPr txBox="1"/>
           <p:nvPr/>
         </p:nvSpPr>
@@ -3340,7 +3454,7 @@
       </p:sp>
       <p:sp>
         <p:nvSpPr>
-          <p:cNvPr id="8" name="TextBox 7"/>
+          <p:cNvPr id="11" name="TextBox 10"/>
           <p:cNvSpPr txBox="1"/>
           <p:nvPr/>
         </p:nvSpPr>
@@ -3375,7 +3489,7 @@
       </p:sp>
       <p:sp>
         <p:nvSpPr>
-          <p:cNvPr id="9" name="Rounded Rectangle 8"/>
+          <p:cNvPr id="12" name="Rounded Rectangle 11"/>
           <p:cNvSpPr/>
           <p:nvPr/>
         </p:nvSpPr>
@@ -3420,7 +3534,7 @@
       </p:sp>
       <p:sp>
         <p:nvSpPr>
-          <p:cNvPr id="10" name="Rectangle 9"/>
+          <p:cNvPr id="13" name="Rectangle 12"/>
           <p:cNvSpPr/>
           <p:nvPr/>
         </p:nvSpPr>
@@ -3463,7 +3577,7 @@
       </p:sp>
       <p:sp>
         <p:nvSpPr>
-          <p:cNvPr id="11" name="TextBox 10"/>
+          <p:cNvPr id="14" name="TextBox 13"/>
           <p:cNvSpPr txBox="1"/>
           <p:nvPr/>
         </p:nvSpPr>
@@ -3498,7 +3612,7 @@
       </p:sp>
       <p:sp>
         <p:nvSpPr>
-          <p:cNvPr id="12" name="TextBox 11"/>
+          <p:cNvPr id="15" name="TextBox 14"/>
           <p:cNvSpPr txBox="1"/>
           <p:nvPr/>
         </p:nvSpPr>
@@ -3533,7 +3647,7 @@
       </p:sp>
       <p:sp>
         <p:nvSpPr>
-          <p:cNvPr id="13" name="Rounded Rectangle 12"/>
+          <p:cNvPr id="16" name="Rounded Rectangle 15"/>
           <p:cNvSpPr/>
           <p:nvPr/>
         </p:nvSpPr>
@@ -3578,7 +3692,7 @@
       </p:sp>
       <p:sp>
         <p:nvSpPr>
-          <p:cNvPr id="14" name="Rectangle 13"/>
+          <p:cNvPr id="17" name="Rectangle 16"/>
           <p:cNvSpPr/>
           <p:nvPr/>
         </p:nvSpPr>
@@ -3621,7 +3735,7 @@
       </p:sp>
       <p:sp>
         <p:nvSpPr>
-          <p:cNvPr id="15" name="TextBox 14"/>
+          <p:cNvPr id="18" name="TextBox 17"/>
           <p:cNvSpPr txBox="1"/>
           <p:nvPr/>
         </p:nvSpPr>
@@ -3656,7 +3770,7 @@
       </p:sp>
       <p:sp>
         <p:nvSpPr>
-          <p:cNvPr id="16" name="TextBox 15"/>
+          <p:cNvPr id="19" name="TextBox 18"/>
           <p:cNvSpPr txBox="1"/>
           <p:nvPr/>
         </p:nvSpPr>
@@ -3691,7 +3805,7 @@
       </p:sp>
       <p:sp>
         <p:nvSpPr>
-          <p:cNvPr id="17" name="TextBox 16"/>
+          <p:cNvPr id="20" name="TextBox 19"/>
           <p:cNvSpPr txBox="1"/>
           <p:nvPr/>
         </p:nvSpPr>
@@ -3824,7 +3938,7 @@
                 </a:solidFill>
                 <a:latin typeface="Aptos"/>
               </a:rPr>
-              <a:t>pay</a:t>
+              <a:t>Pay</a:t>
             </a:r>
           </a:p>
         </p:txBody>
@@ -3837,8 +3951,8 @@
         </p:nvSpPr>
         <p:spPr>
           <a:xfrm>
-            <a:off x="502920" y="256032"/>
-            <a:ext cx="3200400" cy="219456"/>
+            <a:off x="2606040" y="256032"/>
+            <a:ext cx="4572000" cy="219456"/>
           </a:xfrm>
           <a:prstGeom prst="rect">
             <a:avLst/>
@@ -4777,7 +4891,7 @@
                 </a:solidFill>
                 <a:latin typeface="Aptos"/>
               </a:rPr>
-              <a:t>pay</a:t>
+              <a:t>Pay</a:t>
             </a:r>
           </a:p>
         </p:txBody>
@@ -4790,8 +4904,8 @@
         </p:nvSpPr>
         <p:spPr>
           <a:xfrm>
-            <a:off x="502920" y="256032"/>
-            <a:ext cx="3200400" cy="219456"/>
+            <a:off x="2606040" y="256032"/>
+            <a:ext cx="4572000" cy="219456"/>
           </a:xfrm>
           <a:prstGeom prst="rect">
             <a:avLst/>
@@ -6091,7 +6205,7 @@
                 </a:solidFill>
                 <a:latin typeface="Aptos"/>
               </a:rPr>
-              <a:t>pay</a:t>
+              <a:t>Pay</a:t>
             </a:r>
           </a:p>
         </p:txBody>
@@ -6104,8 +6218,8 @@
         </p:nvSpPr>
         <p:spPr>
           <a:xfrm>
-            <a:off x="502920" y="256032"/>
-            <a:ext cx="3200400" cy="219456"/>
+            <a:off x="2606040" y="256032"/>
+            <a:ext cx="4572000" cy="219456"/>
           </a:xfrm>
           <a:prstGeom prst="rect">
             <a:avLst/>
@@ -7225,7 +7339,7 @@
                 </a:solidFill>
                 <a:latin typeface="Aptos"/>
               </a:rPr>
-              <a:t>pay</a:t>
+              <a:t>Pay</a:t>
             </a:r>
           </a:p>
         </p:txBody>
@@ -7238,8 +7352,8 @@
         </p:nvSpPr>
         <p:spPr>
           <a:xfrm>
-            <a:off x="502920" y="256032"/>
-            <a:ext cx="3200400" cy="219456"/>
+            <a:off x="2606040" y="256032"/>
+            <a:ext cx="4572000" cy="219456"/>
           </a:xfrm>
           <a:prstGeom prst="rect">
             <a:avLst/>
@@ -8019,7 +8133,7 @@
                 </a:solidFill>
                 <a:latin typeface="Aptos"/>
               </a:rPr>
-              <a:t>pay</a:t>
+              <a:t>Pay</a:t>
             </a:r>
           </a:p>
         </p:txBody>
@@ -8032,8 +8146,8 @@
         </p:nvSpPr>
         <p:spPr>
           <a:xfrm>
-            <a:off x="502920" y="256032"/>
-            <a:ext cx="3200400" cy="219456"/>
+            <a:off x="2606040" y="256032"/>
+            <a:ext cx="4572000" cy="219456"/>
           </a:xfrm>
           <a:prstGeom prst="rect">
             <a:avLst/>
@@ -9009,7 +9123,7 @@
                 </a:solidFill>
                 <a:latin typeface="Aptos"/>
               </a:rPr>
-              <a:t>pay</a:t>
+              <a:t>Pay</a:t>
             </a:r>
           </a:p>
         </p:txBody>
@@ -9022,8 +9136,8 @@
         </p:nvSpPr>
         <p:spPr>
           <a:xfrm>
-            <a:off x="502920" y="256032"/>
-            <a:ext cx="3200400" cy="219456"/>
+            <a:off x="2606040" y="256032"/>
+            <a:ext cx="4572000" cy="219456"/>
           </a:xfrm>
           <a:prstGeom prst="rect">
             <a:avLst/>
@@ -9647,7 +9761,7 @@
                 </a:solidFill>
                 <a:latin typeface="Aptos"/>
               </a:rPr>
-              <a:t>pay</a:t>
+              <a:t>Pay</a:t>
             </a:r>
           </a:p>
         </p:txBody>
@@ -9660,8 +9774,8 @@
         </p:nvSpPr>
         <p:spPr>
           <a:xfrm>
-            <a:off x="502920" y="256032"/>
-            <a:ext cx="3200400" cy="219456"/>
+            <a:off x="2606040" y="256032"/>
+            <a:ext cx="4572000" cy="219456"/>
           </a:xfrm>
           <a:prstGeom prst="rect">
             <a:avLst/>
@@ -10441,7 +10555,7 @@
                 </a:solidFill>
                 <a:latin typeface="Aptos"/>
               </a:rPr>
-              <a:t>pay</a:t>
+              <a:t>Pay</a:t>
             </a:r>
           </a:p>
         </p:txBody>
@@ -10454,8 +10568,8 @@
         </p:nvSpPr>
         <p:spPr>
           <a:xfrm>
-            <a:off x="502920" y="256032"/>
-            <a:ext cx="3200400" cy="219456"/>
+            <a:off x="2606040" y="256032"/>
+            <a:ext cx="4572000" cy="219456"/>
           </a:xfrm>
           <a:prstGeom prst="rect">
             <a:avLst/>
@@ -11696,7 +11810,7 @@
                 </a:solidFill>
                 <a:latin typeface="Aptos"/>
               </a:rPr>
-              <a:t>pay</a:t>
+              <a:t>Pay</a:t>
             </a:r>
           </a:p>
         </p:txBody>
@@ -11709,8 +11823,8 @@
         </p:nvSpPr>
         <p:spPr>
           <a:xfrm>
-            <a:off x="502920" y="256032"/>
-            <a:ext cx="3200400" cy="219456"/>
+            <a:off x="2606040" y="256032"/>
+            <a:ext cx="4572000" cy="219456"/>
           </a:xfrm>
           <a:prstGeom prst="rect">
             <a:avLst/>
@@ -12791,7 +12905,7 @@
                 </a:solidFill>
                 <a:latin typeface="Aptos"/>
               </a:rPr>
-              <a:t>pay</a:t>
+              <a:t>Pay</a:t>
             </a:r>
           </a:p>
         </p:txBody>
@@ -12804,8 +12918,8 @@
         </p:nvSpPr>
         <p:spPr>
           <a:xfrm>
-            <a:off x="502920" y="256032"/>
-            <a:ext cx="3200400" cy="219456"/>
+            <a:off x="2606040" y="256032"/>
+            <a:ext cx="4572000" cy="219456"/>
           </a:xfrm>
           <a:prstGeom prst="rect">
             <a:avLst/>
@@ -14097,7 +14211,7 @@
                 </a:solidFill>
                 <a:latin typeface="Aptos"/>
               </a:rPr>
-              <a:t>pay</a:t>
+              <a:t>Pay</a:t>
             </a:r>
           </a:p>
         </p:txBody>
@@ -14110,8 +14224,8 @@
         </p:nvSpPr>
         <p:spPr>
           <a:xfrm>
-            <a:off x="502920" y="256032"/>
-            <a:ext cx="3200400" cy="219456"/>
+            <a:off x="2606040" y="256032"/>
+            <a:ext cx="4572000" cy="219456"/>
           </a:xfrm>
           <a:prstGeom prst="rect">
             <a:avLst/>
@@ -14782,7 +14896,7 @@
                 </a:solidFill>
                 <a:latin typeface="Aptos"/>
               </a:rPr>
-              <a:t>pay</a:t>
+              <a:t>Pay</a:t>
             </a:r>
           </a:p>
         </p:txBody>
@@ -14795,8 +14909,8 @@
         </p:nvSpPr>
         <p:spPr>
           <a:xfrm>
-            <a:off x="502920" y="256032"/>
-            <a:ext cx="3200400" cy="219456"/>
+            <a:off x="2606040" y="256032"/>
+            <a:ext cx="4572000" cy="219456"/>
           </a:xfrm>
           <a:prstGeom prst="rect">
             <a:avLst/>
@@ -16359,7 +16473,7 @@
                 </a:solidFill>
                 <a:latin typeface="Aptos"/>
               </a:rPr>
-              <a:t>pay</a:t>
+              <a:t>Pay</a:t>
             </a:r>
           </a:p>
         </p:txBody>
@@ -16372,8 +16486,8 @@
         </p:nvSpPr>
         <p:spPr>
           <a:xfrm>
-            <a:off x="502920" y="256032"/>
-            <a:ext cx="3200400" cy="219456"/>
+            <a:off x="2606040" y="256032"/>
+            <a:ext cx="4572000" cy="219456"/>
           </a:xfrm>
           <a:prstGeom prst="rect">
             <a:avLst/>
@@ -17269,7 +17383,7 @@
                 </a:solidFill>
                 <a:latin typeface="Aptos"/>
               </a:rPr>
-              <a:t>pay</a:t>
+              <a:t>Pay</a:t>
             </a:r>
           </a:p>
         </p:txBody>
@@ -17282,8 +17396,8 @@
         </p:nvSpPr>
         <p:spPr>
           <a:xfrm>
-            <a:off x="502920" y="256032"/>
-            <a:ext cx="3200400" cy="219456"/>
+            <a:off x="2606040" y="256032"/>
+            <a:ext cx="4572000" cy="219456"/>
           </a:xfrm>
           <a:prstGeom prst="rect">
             <a:avLst/>

</xml_diff>

<commit_message>
Simplify Octo partner materials
</commit_message>
<xml_diff>
--- a/deliverables/octo-business/output/B1Pay_Octo_Partner_Proposal.pptx
+++ b/deliverables/octo-business/output/B1Pay_Octo_Partner_Proposal.pptx
@@ -8028,7 +8028,7 @@
                 </a:solidFill>
                 <a:latin typeface="Aptos"/>
               </a:rPr>
-              <a:t>Предложение: совместный discovery workshop на 90 минут и затем короткий sandbox plan.</a:t>
+              <a:t>Предложение: совместная рабочая встреча на 90 минут и согласованный план тестового запуска.</a:t>
             </a:r>
           </a:p>
         </p:txBody>
@@ -9158,7 +9158,7 @@
                 </a:solidFill>
                 <a:latin typeface="Aptos"/>
               </a:rPr>
-              <a:t>14 | DECISION</a:t>
+              <a:t>14 | РЕШЕНИЕ</a:t>
             </a:r>
           </a:p>
         </p:txBody>
@@ -9228,7 +9228,7 @@
                 </a:solidFill>
                 <a:latin typeface="Aptos"/>
               </a:rPr>
-              <a:t>B1Pay готовит UX и технический контур; Octo помогает определить допустимый regulated perimeter</a:t>
+              <a:t>B1Pay готовит сайт и приложение; вместе с Octo мы определяем, какие услуги можно запускать законно и безопасно</a:t>
             </a:r>
           </a:p>
         </p:txBody>
@@ -9376,7 +9376,7 @@
                 </a:solidFill>
                 <a:latin typeface="Aptos"/>
               </a:rPr>
-              <a:t>Предлагаем совместно подтвердить:</a:t>
+              <a:t>Предлагаем вместе подтвердить:</a:t>
             </a:r>
           </a:p>
         </p:txBody>
@@ -9499,7 +9499,7 @@
                 </a:solidFill>
                 <a:latin typeface="Aptos"/>
               </a:rPr>
-              <a:t>Decision pack</a:t>
+              <a:t>Решения для старта</a:t>
             </a:r>
           </a:p>
         </p:txBody>
@@ -9538,7 +9538,7 @@
               </a:defRPr>
             </a:pPr>
             <a:r>
-              <a:t>роль B1Pay + список разрешённых продуктов</a:t>
+              <a:t>роль B1Pay и список разрешённых услуг</a:t>
             </a:r>
           </a:p>
           <a:p>
@@ -9554,7 +9554,7 @@
               </a:defRPr>
             </a:pPr>
             <a:r>
-              <a:t>sandbox/API + security/AML requirements</a:t>
+              <a:t>тестовое подключение и требования к безопасности</a:t>
             </a:r>
           </a:p>
           <a:p>
@@ -9570,7 +9570,7 @@
               </a:defRPr>
             </a:pPr>
             <a:r>
-              <a:t>пилотный продукт, группа, лимиты и KPI</a:t>
+              <a:t>пилотный продукт, группа пользователей, лимиты и показатели</a:t>
             </a:r>
           </a:p>
           <a:p>
@@ -9586,7 +9586,7 @@
               </a:defRPr>
             </a:pPr>
             <a:r>
-              <a:t>go/no-go критерии для P2P/payout</a:t>
+              <a:t>условия, при которых можно будет включить переводы</a:t>
             </a:r>
           </a:p>
         </p:txBody>
@@ -9621,42 +9621,7 @@
                 </a:solidFill>
                 <a:latin typeface="Aptos"/>
               </a:rPr>
-              <a:t>Спасибо. Контакт для workshop: команда B1Pay</a:t>
-            </a:r>
-          </a:p>
-        </p:txBody>
-      </p:sp>
-      <p:sp>
-        <p:nvSpPr>
-          <p:cNvPr id="16" name="TextBox 15"/>
-          <p:cNvSpPr txBox="1"/>
-          <p:nvPr/>
-        </p:nvSpPr>
-        <p:spPr>
-          <a:xfrm>
-            <a:off x="914400" y="5715000"/>
-            <a:ext cx="10332720" cy="274320"/>
-          </a:xfrm>
-          <a:prstGeom prst="rect">
-            <a:avLst/>
-          </a:prstGeom>
-          <a:noFill/>
-        </p:spPr>
-        <p:txBody>
-          <a:bodyPr wrap="square" lIns="36576" rIns="36576" tIns="36576" bIns="36576" anchor="t">
-            <a:spAutoFit/>
-          </a:bodyPr>
-          <a:lstStyle/>
-          <a:p>
-            <a:pPr algn="ctr"/>
-            <a:r>
-              <a:rPr sz="1100" b="0" i="0">
-                <a:solidFill>
-                  <a:srgbClr val="566C87"/>
-                </a:solidFill>
-                <a:latin typeface="Aptos"/>
-              </a:rPr>
-              <a:t>Приложения: business_model.md • architecture.md • platform_architecture.svg</a:t>
+              <a:t>Спасибо. Контакт для рабочей встречи: команда B1Pay</a:t>
             </a:r>
           </a:p>
         </p:txBody>

</xml_diff>